<commit_message>
Format manuscript for Research Policy; fix PR #333 review items (relative figure paths, PPTX decimals, proximity definition)
Co-Authored-By: Tatsuki Onishi <bougtoir@gmail.com>
</commit_message>
<xml_diff>
--- a/researcher_mobility_ode/docs/manuscript_figures.pptx
+++ b/researcher_mobility_ode/docs/manuscript_figures.pptx
@@ -3319,7 +3319,7 @@
               <a:defRPr sz="1400"/>
             </a:pPr>
             <a:r>
-              <a:t>Smaller values mean a smaller proportional change in the listed rate drives the pool to its threshold.</a:t>
+              <a:t>Smaller values mean a smaller proportional change in the listed rate is required to reach the threshold.</a:t>
             </a:r>
           </a:p>
         </p:txBody>
@@ -3495,6 +3495,9 @@
                     <a:bodyPr/>
                     <a:lstStyle/>
                     <a:p>
+                      <a:pPr>
+                        <a:defRPr sz="1000"/>
+                      </a:pPr>
                       <a:r>
                         <a:t>Anglosphere ex-US</a:t>
                       </a:r>
@@ -3507,6 +3510,9 @@
                     <a:bodyPr/>
                     <a:lstStyle/>
                     <a:p>
+                      <a:pPr>
+                        <a:defRPr sz="1000"/>
+                      </a:pPr>
                       <a:r>
                         <a:t>752.12</a:t>
                       </a:r>
@@ -3519,6 +3525,9 @@
                     <a:bodyPr/>
                     <a:lstStyle/>
                     <a:p>
+                      <a:pPr>
+                        <a:defRPr sz="1000"/>
+                      </a:pPr>
                       <a:r>
                         <a:t>119.78</a:t>
                       </a:r>
@@ -3531,6 +3540,9 @@
                     <a:bodyPr/>
                     <a:lstStyle/>
                     <a:p>
+                      <a:pPr>
+                        <a:defRPr sz="1000"/>
+                      </a:pPr>
                       <a:r>
                         <a:t>632.34</a:t>
                       </a:r>
@@ -3543,6 +3555,9 @@
                     <a:bodyPr/>
                     <a:lstStyle/>
                     <a:p>
+                      <a:pPr>
+                        <a:defRPr sz="1000"/>
+                      </a:pPr>
                       <a:r>
                         <a:t>1.55</a:t>
                       </a:r>
@@ -3555,32 +3570,41 @@
                     <a:bodyPr/>
                     <a:lstStyle/>
                     <a:p>
-                      <a:r>
-                        <a:t>0.00</a:t>
-                      </a:r>
-                    </a:p>
-                  </a:txBody>
-                  <a:tcPr/>
-                </a:tc>
-                <a:tc>
-                  <a:txBody>
-                    <a:bodyPr/>
-                    <a:lstStyle/>
-                    <a:p>
-                      <a:r>
-                        <a:t>0.11</a:t>
-                      </a:r>
-                    </a:p>
-                  </a:txBody>
-                  <a:tcPr/>
-                </a:tc>
-                <a:tc>
-                  <a:txBody>
-                    <a:bodyPr/>
-                    <a:lstStyle/>
-                    <a:p>
-                      <a:r>
-                        <a:t>0.00</a:t>
+                      <a:pPr>
+                        <a:defRPr sz="1000"/>
+                      </a:pPr>
+                      <a:r>
+                        <a:t>0.00239</a:t>
+                      </a:r>
+                    </a:p>
+                  </a:txBody>
+                  <a:tcPr/>
+                </a:tc>
+                <a:tc>
+                  <a:txBody>
+                    <a:bodyPr/>
+                    <a:lstStyle/>
+                    <a:p>
+                      <a:pPr>
+                        <a:defRPr sz="1000"/>
+                      </a:pPr>
+                      <a:r>
+                        <a:t>0.11345</a:t>
+                      </a:r>
+                    </a:p>
+                  </a:txBody>
+                  <a:tcPr/>
+                </a:tc>
+                <a:tc>
+                  <a:txBody>
+                    <a:bodyPr/>
+                    <a:lstStyle/>
+                    <a:p>
+                      <a:pPr>
+                        <a:defRPr sz="1000"/>
+                      </a:pPr>
+                      <a:r>
+                        <a:t>0.00478</a:t>
                       </a:r>
                     </a:p>
                   </a:txBody>
@@ -3593,6 +3617,9 @@
                     <a:bodyPr/>
                     <a:lstStyle/>
                     <a:p>
+                      <a:pPr>
+                        <a:defRPr sz="1000"/>
+                      </a:pPr>
                       <a:r>
                         <a:t>Continental Europe</a:t>
                       </a:r>
@@ -3605,6 +3632,9 @@
                     <a:bodyPr/>
                     <a:lstStyle/>
                     <a:p>
+                      <a:pPr>
+                        <a:defRPr sz="1000"/>
+                      </a:pPr>
                       <a:r>
                         <a:t>1156.27</a:t>
                       </a:r>
@@ -3617,6 +3647,9 @@
                     <a:bodyPr/>
                     <a:lstStyle/>
                     <a:p>
+                      <a:pPr>
+                        <a:defRPr sz="1000"/>
+                      </a:pPr>
                       <a:r>
                         <a:t>129.07</a:t>
                       </a:r>
@@ -3629,6 +3662,9 @@
                     <a:bodyPr/>
                     <a:lstStyle/>
                     <a:p>
+                      <a:pPr>
+                        <a:defRPr sz="1000"/>
+                      </a:pPr>
                       <a:r>
                         <a:t>1027.20</a:t>
                       </a:r>
@@ -3641,6 +3677,9 @@
                     <a:bodyPr/>
                     <a:lstStyle/>
                     <a:p>
+                      <a:pPr>
+                        <a:defRPr sz="1000"/>
+                      </a:pPr>
                       <a:r>
                         <a:t>2.76</a:t>
                       </a:r>
@@ -3653,32 +3692,41 @@
                     <a:bodyPr/>
                     <a:lstStyle/>
                     <a:p>
-                      <a:r>
-                        <a:t>0.00</a:t>
-                      </a:r>
-                    </a:p>
-                  </a:txBody>
-                  <a:tcPr/>
-                </a:tc>
-                <a:tc>
-                  <a:txBody>
-                    <a:bodyPr/>
-                    <a:lstStyle/>
-                    <a:p>
-                      <a:r>
-                        <a:t>0.12</a:t>
-                      </a:r>
-                    </a:p>
-                  </a:txBody>
-                  <a:tcPr/>
-                </a:tc>
-                <a:tc>
-                  <a:txBody>
-                    <a:bodyPr/>
-                    <a:lstStyle/>
-                    <a:p>
-                      <a:r>
-                        <a:t>0.01</a:t>
+                      <a:pPr>
+                        <a:defRPr sz="1000"/>
+                      </a:pPr>
+                      <a:r>
+                        <a:t>0.00261</a:t>
+                      </a:r>
+                    </a:p>
+                  </a:txBody>
+                  <a:tcPr/>
+                </a:tc>
+                <a:tc>
+                  <a:txBody>
+                    <a:bodyPr/>
+                    <a:lstStyle/>
+                    <a:p>
+                      <a:pPr>
+                        <a:defRPr sz="1000"/>
+                      </a:pPr>
+                      <a:r>
+                        <a:t>0.12276</a:t>
+                      </a:r>
+                    </a:p>
+                  </a:txBody>
+                  <a:tcPr/>
+                </a:tc>
+                <a:tc>
+                  <a:txBody>
+                    <a:bodyPr/>
+                    <a:lstStyle/>
+                    <a:p>
+                      <a:pPr>
+                        <a:defRPr sz="1000"/>
+                      </a:pPr>
+                      <a:r>
+                        <a:t>0.00523</a:t>
                       </a:r>
                     </a:p>
                   </a:txBody>
@@ -3691,6 +3739,9 @@
                     <a:bodyPr/>
                     <a:lstStyle/>
                     <a:p>
+                      <a:pPr>
+                        <a:defRPr sz="1000"/>
+                      </a:pPr>
                       <a:r>
                         <a:t>Hindu</a:t>
                       </a:r>
@@ -3703,6 +3754,9 @@
                     <a:bodyPr/>
                     <a:lstStyle/>
                     <a:p>
+                      <a:pPr>
+                        <a:defRPr sz="1000"/>
+                      </a:pPr>
                       <a:r>
                         <a:t>1497.37</a:t>
                       </a:r>
@@ -3715,6 +3769,9 @@
                     <a:bodyPr/>
                     <a:lstStyle/>
                     <a:p>
+                      <a:pPr>
+                        <a:defRPr sz="1000"/>
+                      </a:pPr>
                       <a:r>
                         <a:t>66.04</a:t>
                       </a:r>
@@ -3727,6 +3784,9 @@
                     <a:bodyPr/>
                     <a:lstStyle/>
                     <a:p>
+                      <a:pPr>
+                        <a:defRPr sz="1000"/>
+                      </a:pPr>
                       <a:r>
                         <a:t>1431.33</a:t>
                       </a:r>
@@ -3739,6 +3799,9 @@
                     <a:bodyPr/>
                     <a:lstStyle/>
                     <a:p>
+                      <a:pPr>
+                        <a:defRPr sz="1000"/>
+                      </a:pPr>
                       <a:r>
                         <a:t>1.52</a:t>
                       </a:r>
@@ -3751,32 +3814,41 @@
                     <a:bodyPr/>
                     <a:lstStyle/>
                     <a:p>
-                      <a:r>
-                        <a:t>0.00</a:t>
-                      </a:r>
-                    </a:p>
-                  </a:txBody>
-                  <a:tcPr/>
-                </a:tc>
-                <a:tc>
-                  <a:txBody>
-                    <a:bodyPr/>
-                    <a:lstStyle/>
-                    <a:p>
-                      <a:r>
-                        <a:t>0.12</a:t>
-                      </a:r>
-                    </a:p>
-                  </a:txBody>
-                  <a:tcPr/>
-                </a:tc>
-                <a:tc>
-                  <a:txBody>
-                    <a:bodyPr/>
-                    <a:lstStyle/>
-                    <a:p>
-                      <a:r>
-                        <a:t>0.00</a:t>
+                      <a:pPr>
+                        <a:defRPr sz="1000"/>
+                      </a:pPr>
+                      <a:r>
+                        <a:t>0.00106</a:t>
+                      </a:r>
+                    </a:p>
+                  </a:txBody>
+                  <a:tcPr/>
+                </a:tc>
+                <a:tc>
+                  <a:txBody>
+                    <a:bodyPr/>
+                    <a:lstStyle/>
+                    <a:p>
+                      <a:pPr>
+                        <a:defRPr sz="1000"/>
+                      </a:pPr>
+                      <a:r>
+                        <a:t>0.11765</a:t>
+                      </a:r>
+                    </a:p>
+                  </a:txBody>
+                  <a:tcPr/>
+                </a:tc>
+                <a:tc>
+                  <a:txBody>
+                    <a:bodyPr/>
+                    <a:lstStyle/>
+                    <a:p>
+                      <a:pPr>
+                        <a:defRPr sz="1000"/>
+                      </a:pPr>
+                      <a:r>
+                        <a:t>0.00213</a:t>
                       </a:r>
                     </a:p>
                   </a:txBody>
@@ -3789,6 +3861,9 @@
                     <a:bodyPr/>
                     <a:lstStyle/>
                     <a:p>
+                      <a:pPr>
+                        <a:defRPr sz="1000"/>
+                      </a:pPr>
                       <a:r>
                         <a:t>Islamic</a:t>
                       </a:r>
@@ -3801,6 +3876,9 @@
                     <a:bodyPr/>
                     <a:lstStyle/>
                     <a:p>
+                      <a:pPr>
+                        <a:defRPr sz="1000"/>
+                      </a:pPr>
                       <a:r>
                         <a:t>892.42</a:t>
                       </a:r>
@@ -3813,6 +3891,9 @@
                     <a:bodyPr/>
                     <a:lstStyle/>
                     <a:p>
+                      <a:pPr>
+                        <a:defRPr sz="1000"/>
+                      </a:pPr>
                       <a:r>
                         <a:t>126.52</a:t>
                       </a:r>
@@ -3825,6 +3906,9 @@
                     <a:bodyPr/>
                     <a:lstStyle/>
                     <a:p>
+                      <a:pPr>
+                        <a:defRPr sz="1000"/>
+                      </a:pPr>
                       <a:r>
                         <a:t>765.89</a:t>
                       </a:r>
@@ -3837,6 +3921,9 @@
                     <a:bodyPr/>
                     <a:lstStyle/>
                     <a:p>
+                      <a:pPr>
+                        <a:defRPr sz="1000"/>
+                      </a:pPr>
                       <a:r>
                         <a:t>1.16</a:t>
                       </a:r>
@@ -3849,32 +3936,41 @@
                     <a:bodyPr/>
                     <a:lstStyle/>
                     <a:p>
-                      <a:r>
-                        <a:t>0.00</a:t>
-                      </a:r>
-                    </a:p>
-                  </a:txBody>
-                  <a:tcPr/>
-                </a:tc>
-                <a:tc>
-                  <a:txBody>
-                    <a:bodyPr/>
-                    <a:lstStyle/>
-                    <a:p>
-                      <a:r>
-                        <a:t>0.13</a:t>
-                      </a:r>
-                    </a:p>
-                  </a:txBody>
-                  <a:tcPr/>
-                </a:tc>
-                <a:tc>
-                  <a:txBody>
-                    <a:bodyPr/>
-                    <a:lstStyle/>
-                    <a:p>
-                      <a:r>
-                        <a:t>0.00</a:t>
+                      <a:pPr>
+                        <a:defRPr sz="1000"/>
+                      </a:pPr>
+                      <a:r>
+                        <a:t>0.00141</a:t>
+                      </a:r>
+                    </a:p>
+                  </a:txBody>
+                  <a:tcPr/>
+                </a:tc>
+                <a:tc>
+                  <a:txBody>
+                    <a:bodyPr/>
+                    <a:lstStyle/>
+                    <a:p>
+                      <a:pPr>
+                        <a:defRPr sz="1000"/>
+                      </a:pPr>
+                      <a:r>
+                        <a:t>0.13072</a:t>
+                      </a:r>
+                    </a:p>
+                  </a:txBody>
+                  <a:tcPr/>
+                </a:tc>
+                <a:tc>
+                  <a:txBody>
+                    <a:bodyPr/>
+                    <a:lstStyle/>
+                    <a:p>
+                      <a:pPr>
+                        <a:defRPr sz="1000"/>
+                      </a:pPr>
+                      <a:r>
+                        <a:t>0.00282</a:t>
                       </a:r>
                     </a:p>
                   </a:txBody>
@@ -3887,6 +3983,9 @@
                     <a:bodyPr/>
                     <a:lstStyle/>
                     <a:p>
+                      <a:pPr>
+                        <a:defRPr sz="1000"/>
+                      </a:pPr>
                       <a:r>
                         <a:t>Japanese</a:t>
                       </a:r>
@@ -3899,6 +3998,9 @@
                     <a:bodyPr/>
                     <a:lstStyle/>
                     <a:p>
+                      <a:pPr>
+                        <a:defRPr sz="1000"/>
+                      </a:pPr>
                       <a:r>
                         <a:t>206.81</a:t>
                       </a:r>
@@ -3911,6 +4013,9 @@
                     <a:bodyPr/>
                     <a:lstStyle/>
                     <a:p>
+                      <a:pPr>
+                        <a:defRPr sz="1000"/>
+                      </a:pPr>
                       <a:r>
                         <a:t>50.48</a:t>
                       </a:r>
@@ -3923,6 +4028,9 @@
                     <a:bodyPr/>
                     <a:lstStyle/>
                     <a:p>
+                      <a:pPr>
+                        <a:defRPr sz="1000"/>
+                      </a:pPr>
                       <a:r>
                         <a:t>156.33</a:t>
                       </a:r>
@@ -3935,6 +4043,9 @@
                     <a:bodyPr/>
                     <a:lstStyle/>
                     <a:p>
+                      <a:pPr>
+                        <a:defRPr sz="1000"/>
+                      </a:pPr>
                       <a:r>
                         <a:t>1.42</a:t>
                       </a:r>
@@ -3947,32 +4058,41 @@
                     <a:bodyPr/>
                     <a:lstStyle/>
                     <a:p>
-                      <a:r>
-                        <a:t>0.01</a:t>
-                      </a:r>
-                    </a:p>
-                  </a:txBody>
-                  <a:tcPr/>
-                </a:tc>
-                <a:tc>
-                  <a:txBody>
-                    <a:bodyPr/>
-                    <a:lstStyle/>
-                    <a:p>
-                      <a:r>
-                        <a:t>0.14</a:t>
-                      </a:r>
-                    </a:p>
-                  </a:txBody>
-                  <a:tcPr/>
-                </a:tc>
-                <a:tc>
-                  <a:txBody>
-                    <a:bodyPr/>
-                    <a:lstStyle/>
-                    <a:p>
-                      <a:r>
-                        <a:t>0.02</a:t>
+                      <a:pPr>
+                        <a:defRPr sz="1000"/>
+                      </a:pPr>
+                      <a:r>
+                        <a:t>0.00993</a:t>
+                      </a:r>
+                    </a:p>
+                  </a:txBody>
+                  <a:tcPr/>
+                </a:tc>
+                <a:tc>
+                  <a:txBody>
+                    <a:bodyPr/>
+                    <a:lstStyle/>
+                    <a:p>
+                      <a:pPr>
+                        <a:defRPr sz="1000"/>
+                      </a:pPr>
+                      <a:r>
+                        <a:t>0.13904</a:t>
+                      </a:r>
+                    </a:p>
+                  </a:txBody>
+                  <a:tcPr/>
+                </a:tc>
+                <a:tc>
+                  <a:txBody>
+                    <a:bodyPr/>
+                    <a:lstStyle/>
+                    <a:p>
+                      <a:pPr>
+                        <a:defRPr sz="1000"/>
+                      </a:pPr>
+                      <a:r>
+                        <a:t>0.01985</a:t>
                       </a:r>
                     </a:p>
                   </a:txBody>
@@ -3985,6 +4105,9 @@
                     <a:bodyPr/>
                     <a:lstStyle/>
                     <a:p>
+                      <a:pPr>
+                        <a:defRPr sz="1000"/>
+                      </a:pPr>
                       <a:r>
                         <a:t>Other Civilizations</a:t>
                       </a:r>
@@ -3997,6 +4120,9 @@
                     <a:bodyPr/>
                     <a:lstStyle/>
                     <a:p>
+                      <a:pPr>
+                        <a:defRPr sz="1000"/>
+                      </a:pPr>
                       <a:r>
                         <a:t>424.70</a:t>
                       </a:r>
@@ -4009,6 +4135,9 @@
                     <a:bodyPr/>
                     <a:lstStyle/>
                     <a:p>
+                      <a:pPr>
+                        <a:defRPr sz="1000"/>
+                      </a:pPr>
                       <a:r>
                         <a:t>104.60</a:t>
                       </a:r>
@@ -4021,6 +4150,9 @@
                     <a:bodyPr/>
                     <a:lstStyle/>
                     <a:p>
+                      <a:pPr>
+                        <a:defRPr sz="1000"/>
+                      </a:pPr>
                       <a:r>
                         <a:t>320.10</a:t>
                       </a:r>
@@ -4033,6 +4165,9 @@
                     <a:bodyPr/>
                     <a:lstStyle/>
                     <a:p>
+                      <a:pPr>
+                        <a:defRPr sz="1000"/>
+                      </a:pPr>
                       <a:r>
                         <a:t>1.15</a:t>
                       </a:r>
@@ -4045,32 +4180,41 @@
                     <a:bodyPr/>
                     <a:lstStyle/>
                     <a:p>
-                      <a:r>
-                        <a:t>0.00</a:t>
-                      </a:r>
-                    </a:p>
-                  </a:txBody>
-                  <a:tcPr/>
-                </a:tc>
-                <a:tc>
-                  <a:txBody>
-                    <a:bodyPr/>
-                    <a:lstStyle/>
-                    <a:p>
-                      <a:r>
-                        <a:t>0.13</a:t>
-                      </a:r>
-                    </a:p>
-                  </a:txBody>
-                  <a:tcPr/>
-                </a:tc>
-                <a:tc>
-                  <a:txBody>
-                    <a:bodyPr/>
-                    <a:lstStyle/>
-                    <a:p>
-                      <a:r>
-                        <a:t>0.01</a:t>
+                      <a:pPr>
+                        <a:defRPr sz="1000"/>
+                      </a:pPr>
+                      <a:r>
+                        <a:t>0.00310</a:t>
+                      </a:r>
+                    </a:p>
+                  </a:txBody>
+                  <a:tcPr/>
+                </a:tc>
+                <a:tc>
+                  <a:txBody>
+                    <a:bodyPr/>
+                    <a:lstStyle/>
+                    <a:p>
+                      <a:pPr>
+                        <a:defRPr sz="1000"/>
+                      </a:pPr>
+                      <a:r>
+                        <a:t>0.13072</a:t>
+                      </a:r>
+                    </a:p>
+                  </a:txBody>
+                  <a:tcPr/>
+                </a:tc>
+                <a:tc>
+                  <a:txBody>
+                    <a:bodyPr/>
+                    <a:lstStyle/>
+                    <a:p>
+                      <a:pPr>
+                        <a:defRPr sz="1000"/>
+                      </a:pPr>
+                      <a:r>
+                        <a:t>0.00620</a:t>
                       </a:r>
                     </a:p>
                   </a:txBody>
@@ -4083,6 +4227,9 @@
                     <a:bodyPr/>
                     <a:lstStyle/>
                     <a:p>
+                      <a:pPr>
+                        <a:defRPr sz="1000"/>
+                      </a:pPr>
                       <a:r>
                         <a:t>Other Western</a:t>
                       </a:r>
@@ -4095,6 +4242,9 @@
                     <a:bodyPr/>
                     <a:lstStyle/>
                     <a:p>
+                      <a:pPr>
+                        <a:defRPr sz="1000"/>
+                      </a:pPr>
                       <a:r>
                         <a:t>513.12</a:t>
                       </a:r>
@@ -4107,6 +4257,9 @@
                     <a:bodyPr/>
                     <a:lstStyle/>
                     <a:p>
+                      <a:pPr>
+                        <a:defRPr sz="1000"/>
+                      </a:pPr>
                       <a:r>
                         <a:t>57.17</a:t>
                       </a:r>
@@ -4119,6 +4272,9 @@
                     <a:bodyPr/>
                     <a:lstStyle/>
                     <a:p>
+                      <a:pPr>
+                        <a:defRPr sz="1000"/>
+                      </a:pPr>
                       <a:r>
                         <a:t>455.95</a:t>
                       </a:r>
@@ -4131,6 +4287,9 @@
                     <a:bodyPr/>
                     <a:lstStyle/>
                     <a:p>
+                      <a:pPr>
+                        <a:defRPr sz="1000"/>
+                      </a:pPr>
                       <a:r>
                         <a:t>0.87</a:t>
                       </a:r>
@@ -4143,32 +4302,41 @@
                     <a:bodyPr/>
                     <a:lstStyle/>
                     <a:p>
-                      <a:r>
-                        <a:t>0.00</a:t>
-                      </a:r>
-                    </a:p>
-                  </a:txBody>
-                  <a:tcPr/>
-                </a:tc>
-                <a:tc>
-                  <a:txBody>
-                    <a:bodyPr/>
-                    <a:lstStyle/>
-                    <a:p>
-                      <a:r>
-                        <a:t>0.18</a:t>
-                      </a:r>
-                    </a:p>
-                  </a:txBody>
-                  <a:tcPr/>
-                </a:tc>
-                <a:tc>
-                  <a:txBody>
-                    <a:bodyPr/>
-                    <a:lstStyle/>
-                    <a:p>
-                      <a:r>
-                        <a:t>0.00</a:t>
+                      <a:pPr>
+                        <a:defRPr sz="1000"/>
+                      </a:pPr>
+                      <a:r>
+                        <a:t>0.00200</a:t>
+                      </a:r>
+                    </a:p>
+                  </a:txBody>
+                  <a:tcPr/>
+                </a:tc>
+                <a:tc>
+                  <a:txBody>
+                    <a:bodyPr/>
+                    <a:lstStyle/>
+                    <a:p>
+                      <a:pPr>
+                        <a:defRPr sz="1000"/>
+                      </a:pPr>
+                      <a:r>
+                        <a:t>0.17647</a:t>
+                      </a:r>
+                    </a:p>
+                  </a:txBody>
+                  <a:tcPr/>
+                </a:tc>
+                <a:tc>
+                  <a:txBody>
+                    <a:bodyPr/>
+                    <a:lstStyle/>
+                    <a:p>
+                      <a:pPr>
+                        <a:defRPr sz="1000"/>
+                      </a:pPr>
+                      <a:r>
+                        <a:t>0.00400</a:t>
                       </a:r>
                     </a:p>
                   </a:txBody>
@@ -4181,6 +4349,9 @@
                     <a:bodyPr/>
                     <a:lstStyle/>
                     <a:p>
+                      <a:pPr>
+                        <a:defRPr sz="1000"/>
+                      </a:pPr>
                       <a:r>
                         <a:t>Sinic</a:t>
                       </a:r>
@@ -4193,6 +4364,9 @@
                     <a:bodyPr/>
                     <a:lstStyle/>
                     <a:p>
+                      <a:pPr>
+                        <a:defRPr sz="1000"/>
+                      </a:pPr>
                       <a:r>
                         <a:t>1783.64</a:t>
                       </a:r>
@@ -4205,6 +4379,9 @@
                     <a:bodyPr/>
                     <a:lstStyle/>
                     <a:p>
+                      <a:pPr>
+                        <a:defRPr sz="1000"/>
+                      </a:pPr>
                       <a:r>
                         <a:t>112.34</a:t>
                       </a:r>
@@ -4217,6 +4394,9 @@
                     <a:bodyPr/>
                     <a:lstStyle/>
                     <a:p>
+                      <a:pPr>
+                        <a:defRPr sz="1000"/>
+                      </a:pPr>
                       <a:r>
                         <a:t>1671.29</a:t>
                       </a:r>
@@ -4229,6 +4409,9 @@
                     <a:bodyPr/>
                     <a:lstStyle/>
                     <a:p>
+                      <a:pPr>
+                        <a:defRPr sz="1000"/>
+                      </a:pPr>
                       <a:r>
                         <a:t>2.38</a:t>
                       </a:r>
@@ -4241,32 +4424,41 @@
                     <a:bodyPr/>
                     <a:lstStyle/>
                     <a:p>
-                      <a:r>
-                        <a:t>0.00</a:t>
-                      </a:r>
-                    </a:p>
-                  </a:txBody>
-                  <a:tcPr/>
-                </a:tc>
-                <a:tc>
-                  <a:txBody>
-                    <a:bodyPr/>
-                    <a:lstStyle/>
-                    <a:p>
-                      <a:r>
-                        <a:t>0.12</a:t>
-                      </a:r>
-                    </a:p>
-                  </a:txBody>
-                  <a:tcPr/>
-                </a:tc>
-                <a:tc>
-                  <a:txBody>
-                    <a:bodyPr/>
-                    <a:lstStyle/>
-                    <a:p>
-                      <a:r>
-                        <a:t>0.00</a:t>
+                      <a:pPr>
+                        <a:defRPr sz="1000"/>
+                      </a:pPr>
+                      <a:r>
+                        <a:t>0.00140</a:t>
+                      </a:r>
+                    </a:p>
+                  </a:txBody>
+                  <a:tcPr/>
+                </a:tc>
+                <a:tc>
+                  <a:txBody>
+                    <a:bodyPr/>
+                    <a:lstStyle/>
+                    <a:p>
+                      <a:pPr>
+                        <a:defRPr sz="1000"/>
+                      </a:pPr>
+                      <a:r>
+                        <a:t>0.12059</a:t>
+                      </a:r>
+                    </a:p>
+                  </a:txBody>
+                  <a:tcPr/>
+                </a:tc>
+                <a:tc>
+                  <a:txBody>
+                    <a:bodyPr/>
+                    <a:lstStyle/>
+                    <a:p>
+                      <a:pPr>
+                        <a:defRPr sz="1000"/>
+                      </a:pPr>
+                      <a:r>
+                        <a:t>0.00281</a:t>
                       </a:r>
                     </a:p>
                   </a:txBody>
@@ -4279,6 +4471,9 @@
                     <a:bodyPr/>
                     <a:lstStyle/>
                     <a:p>
+                      <a:pPr>
+                        <a:defRPr sz="1000"/>
+                      </a:pPr>
                       <a:r>
                         <a:t>United States</a:t>
                       </a:r>
@@ -4291,6 +4486,9 @@
                     <a:bodyPr/>
                     <a:lstStyle/>
                     <a:p>
+                      <a:pPr>
+                        <a:defRPr sz="1000"/>
+                      </a:pPr>
                       <a:r>
                         <a:t>801.70</a:t>
                       </a:r>
@@ -4303,6 +4501,9 @@
                     <a:bodyPr/>
                     <a:lstStyle/>
                     <a:p>
+                      <a:pPr>
+                        <a:defRPr sz="1000"/>
+                      </a:pPr>
                       <a:r>
                         <a:t>132.49</a:t>
                       </a:r>
@@ -4315,6 +4516,9 @@
                     <a:bodyPr/>
                     <a:lstStyle/>
                     <a:p>
+                      <a:pPr>
+                        <a:defRPr sz="1000"/>
+                      </a:pPr>
                       <a:r>
                         <a:t>669.21</a:t>
                       </a:r>
@@ -4327,6 +4531,9 @@
                     <a:bodyPr/>
                     <a:lstStyle/>
                     <a:p>
+                      <a:pPr>
+                        <a:defRPr sz="1000"/>
+                      </a:pPr>
                       <a:r>
                         <a:t>2.83</a:t>
                       </a:r>
@@ -4339,32 +4546,41 @@
                     <a:bodyPr/>
                     <a:lstStyle/>
                     <a:p>
-                      <a:r>
-                        <a:t>0.00</a:t>
-                      </a:r>
-                    </a:p>
-                  </a:txBody>
-                  <a:tcPr/>
-                </a:tc>
-                <a:tc>
-                  <a:txBody>
-                    <a:bodyPr/>
-                    <a:lstStyle/>
-                    <a:p>
-                      <a:r>
-                        <a:t>0.11</a:t>
-                      </a:r>
-                    </a:p>
-                  </a:txBody>
-                  <a:tcPr/>
-                </a:tc>
-                <a:tc>
-                  <a:txBody>
-                    <a:bodyPr/>
-                    <a:lstStyle/>
-                    <a:p>
-                      <a:r>
-                        <a:t>0.01</a:t>
+                      <a:pPr>
+                        <a:defRPr sz="1000"/>
+                      </a:pPr>
+                      <a:r>
+                        <a:t>0.00396</a:t>
+                      </a:r>
+                    </a:p>
+                  </a:txBody>
+                  <a:tcPr/>
+                </a:tc>
+                <a:tc>
+                  <a:txBody>
+                    <a:bodyPr/>
+                    <a:lstStyle/>
+                    <a:p>
+                      <a:pPr>
+                        <a:defRPr sz="1000"/>
+                      </a:pPr>
+                      <a:r>
+                        <a:t>0.10504</a:t>
+                      </a:r>
+                    </a:p>
+                  </a:txBody>
+                  <a:tcPr/>
+                </a:tc>
+                <a:tc>
+                  <a:txBody>
+                    <a:bodyPr/>
+                    <a:lstStyle/>
+                    <a:p>
+                      <a:pPr>
+                        <a:defRPr sz="1000"/>
+                      </a:pPr>
+                      <a:r>
+                        <a:t>0.00791</a:t>
                       </a:r>
                     </a:p>
                   </a:txBody>
@@ -4533,6 +4749,9 @@
                     <a:bodyPr/>
                     <a:lstStyle/>
                     <a:p>
+                      <a:pPr>
+                        <a:defRPr sz="1000"/>
+                      </a:pPr>
                       <a:r>
                         <a:t>Anglosphere ex-US</a:t>
                       </a:r>
@@ -4545,6 +4764,9 @@
                     <a:bodyPr/>
                     <a:lstStyle/>
                     <a:p>
+                      <a:pPr>
+                        <a:defRPr sz="1000"/>
+                      </a:pPr>
                       <a:r>
                         <a:t>d</a:t>
                       </a:r>
@@ -4557,6 +4779,9 @@
                     <a:bodyPr/>
                     <a:lstStyle/>
                     <a:p>
+                      <a:pPr>
+                        <a:defRPr sz="1000"/>
+                      </a:pPr>
                       <a:r>
                         <a:t>-2.162</a:t>
                       </a:r>
@@ -4569,6 +4794,9 @@
                     <a:bodyPr/>
                     <a:lstStyle/>
                     <a:p>
+                      <a:pPr>
+                        <a:defRPr sz="1000"/>
+                      </a:pPr>
                       <a:r>
                         <a:t>p_D</a:t>
                       </a:r>
@@ -4581,6 +4809,9 @@
                     <a:bodyPr/>
                     <a:lstStyle/>
                     <a:p>
+                      <a:pPr>
+                        <a:defRPr sz="1000"/>
+                      </a:pPr>
                       <a:r>
                         <a:t>0.116</a:t>
                       </a:r>
@@ -4593,6 +4824,9 @@
                     <a:bodyPr/>
                     <a:lstStyle/>
                     <a:p>
+                      <a:pPr>
+                        <a:defRPr sz="1000"/>
+                      </a:pPr>
                       <a:r>
                         <a:t>beta</a:t>
                       </a:r>
@@ -4605,6 +4839,9 @@
                     <a:bodyPr/>
                     <a:lstStyle/>
                     <a:p>
+                      <a:pPr>
+                        <a:defRPr sz="1000"/>
+                      </a:pPr>
                       <a:r>
                         <a:t>0.046</a:t>
                       </a:r>
@@ -4619,6 +4856,9 @@
                     <a:bodyPr/>
                     <a:lstStyle/>
                     <a:p>
+                      <a:pPr>
+                        <a:defRPr sz="1000"/>
+                      </a:pPr>
                       <a:r>
                         <a:t>Continental Europe</a:t>
                       </a:r>
@@ -4631,6 +4871,9 @@
                     <a:bodyPr/>
                     <a:lstStyle/>
                     <a:p>
+                      <a:pPr>
+                        <a:defRPr sz="1000"/>
+                      </a:pPr>
                       <a:r>
                         <a:t>d</a:t>
                       </a:r>
@@ -4643,6 +4886,9 @@
                     <a:bodyPr/>
                     <a:lstStyle/>
                     <a:p>
+                      <a:pPr>
+                        <a:defRPr sz="1000"/>
+                      </a:pPr>
                       <a:r>
                         <a:t>-2.100</a:t>
                       </a:r>
@@ -4655,6 +4901,9 @@
                     <a:bodyPr/>
                     <a:lstStyle/>
                     <a:p>
+                      <a:pPr>
+                        <a:defRPr sz="1000"/>
+                      </a:pPr>
                       <a:r>
                         <a:t>p_D</a:t>
                       </a:r>
@@ -4667,6 +4916,9 @@
                     <a:bodyPr/>
                     <a:lstStyle/>
                     <a:p>
+                      <a:pPr>
+                        <a:defRPr sz="1000"/>
+                      </a:pPr>
                       <a:r>
                         <a:t>0.067</a:t>
                       </a:r>
@@ -4679,6 +4931,9 @@
                     <a:bodyPr/>
                     <a:lstStyle/>
                     <a:p>
+                      <a:pPr>
+                        <a:defRPr sz="1000"/>
+                      </a:pPr>
                       <a:r>
                         <a:t>beta</a:t>
                       </a:r>
@@ -4691,6 +4946,9 @@
                     <a:bodyPr/>
                     <a:lstStyle/>
                     <a:p>
+                      <a:pPr>
+                        <a:defRPr sz="1000"/>
+                      </a:pPr>
                       <a:r>
                         <a:t>0.047</a:t>
                       </a:r>
@@ -4705,6 +4963,9 @@
                     <a:bodyPr/>
                     <a:lstStyle/>
                     <a:p>
+                      <a:pPr>
+                        <a:defRPr sz="1000"/>
+                      </a:pPr>
                       <a:r>
                         <a:t>Hindu</a:t>
                       </a:r>
@@ -4717,6 +4978,9 @@
                     <a:bodyPr/>
                     <a:lstStyle/>
                     <a:p>
+                      <a:pPr>
+                        <a:defRPr sz="1000"/>
+                      </a:pPr>
                       <a:r>
                         <a:t>d</a:t>
                       </a:r>
@@ -4729,6 +4993,9 @@
                     <a:bodyPr/>
                     <a:lstStyle/>
                     <a:p>
+                      <a:pPr>
+                        <a:defRPr sz="1000"/>
+                      </a:pPr>
                       <a:r>
                         <a:t>-2.011</a:t>
                       </a:r>
@@ -4741,6 +5008,9 @@
                     <a:bodyPr/>
                     <a:lstStyle/>
                     <a:p>
+                      <a:pPr>
+                        <a:defRPr sz="1000"/>
+                      </a:pPr>
                       <a:r>
                         <a:t>p_D</a:t>
                       </a:r>
@@ -4753,6 +5023,9 @@
                     <a:bodyPr/>
                     <a:lstStyle/>
                     <a:p>
+                      <a:pPr>
+                        <a:defRPr sz="1000"/>
+                      </a:pPr>
                       <a:r>
                         <a:t>0.038</a:t>
                       </a:r>
@@ -4765,6 +5038,9 @@
                     <a:bodyPr/>
                     <a:lstStyle/>
                     <a:p>
+                      <a:pPr>
+                        <a:defRPr sz="1000"/>
+                      </a:pPr>
                       <a:r>
                         <a:t>h_D</a:t>
                       </a:r>
@@ -4777,6 +5053,9 @@
                     <a:bodyPr/>
                     <a:lstStyle/>
                     <a:p>
+                      <a:pPr>
+                        <a:defRPr sz="1000"/>
+                      </a:pPr>
                       <a:r>
                         <a:t>0.013</a:t>
                       </a:r>
@@ -4791,6 +5070,9 @@
                     <a:bodyPr/>
                     <a:lstStyle/>
                     <a:p>
+                      <a:pPr>
+                        <a:defRPr sz="1000"/>
+                      </a:pPr>
                       <a:r>
                         <a:t>Islamic</a:t>
                       </a:r>
@@ -4803,6 +5085,9 @@
                     <a:bodyPr/>
                     <a:lstStyle/>
                     <a:p>
+                      <a:pPr>
+                        <a:defRPr sz="1000"/>
+                      </a:pPr>
                       <a:r>
                         <a:t>d</a:t>
                       </a:r>
@@ -4815,6 +5100,9 @@
                     <a:bodyPr/>
                     <a:lstStyle/>
                     <a:p>
+                      <a:pPr>
+                        <a:defRPr sz="1000"/>
+                      </a:pPr>
                       <a:r>
                         <a:t>-2.051</a:t>
                       </a:r>
@@ -4827,6 +5115,9 @@
                     <a:bodyPr/>
                     <a:lstStyle/>
                     <a:p>
+                      <a:pPr>
+                        <a:defRPr sz="1000"/>
+                      </a:pPr>
                       <a:r>
                         <a:t>p_D</a:t>
                       </a:r>
@@ -4839,6 +5130,9 @@
                     <a:bodyPr/>
                     <a:lstStyle/>
                     <a:p>
+                      <a:pPr>
+                        <a:defRPr sz="1000"/>
+                      </a:pPr>
                       <a:r>
                         <a:t>0.057</a:t>
                       </a:r>
@@ -4851,6 +5145,9 @@
                     <a:bodyPr/>
                     <a:lstStyle/>
                     <a:p>
+                      <a:pPr>
+                        <a:defRPr sz="1000"/>
+                      </a:pPr>
                       <a:r>
                         <a:t>h_D</a:t>
                       </a:r>
@@ -4863,6 +5160,9 @@
                     <a:bodyPr/>
                     <a:lstStyle/>
                     <a:p>
+                      <a:pPr>
+                        <a:defRPr sz="1000"/>
+                      </a:pPr>
                       <a:r>
                         <a:t>0.022</a:t>
                       </a:r>
@@ -4877,6 +5177,9 @@
                     <a:bodyPr/>
                     <a:lstStyle/>
                     <a:p>
+                      <a:pPr>
+                        <a:defRPr sz="1000"/>
+                      </a:pPr>
                       <a:r>
                         <a:t>Japanese</a:t>
                       </a:r>
@@ -4889,6 +5192,9 @@
                     <a:bodyPr/>
                     <a:lstStyle/>
                     <a:p>
+                      <a:pPr>
+                        <a:defRPr sz="1000"/>
+                      </a:pPr>
                       <a:r>
                         <a:t>d</a:t>
                       </a:r>
@@ -4901,6 +5207,9 @@
                     <a:bodyPr/>
                     <a:lstStyle/>
                     <a:p>
+                      <a:pPr>
+                        <a:defRPr sz="1000"/>
+                      </a:pPr>
                       <a:r>
                         <a:t>-2.317</a:t>
                       </a:r>
@@ -4913,6 +5222,9 @@
                     <a:bodyPr/>
                     <a:lstStyle/>
                     <a:p>
+                      <a:pPr>
+                        <a:defRPr sz="1000"/>
+                      </a:pPr>
                       <a:r>
                         <a:t>p_D</a:t>
                       </a:r>
@@ -4925,6 +5237,9 @@
                     <a:bodyPr/>
                     <a:lstStyle/>
                     <a:p>
+                      <a:pPr>
+                        <a:defRPr sz="1000"/>
+                      </a:pPr>
                       <a:r>
                         <a:t>0.233</a:t>
                       </a:r>
@@ -4937,6 +5252,9 @@
                     <a:bodyPr/>
                     <a:lstStyle/>
                     <a:p>
+                      <a:pPr>
+                        <a:defRPr sz="1000"/>
+                      </a:pPr>
                       <a:r>
                         <a:t>h_D</a:t>
                       </a:r>
@@ -4949,6 +5267,9 @@
                     <a:bodyPr/>
                     <a:lstStyle/>
                     <a:p>
+                      <a:pPr>
+                        <a:defRPr sz="1000"/>
+                      </a:pPr>
                       <a:r>
                         <a:t>0.111</a:t>
                       </a:r>
@@ -4963,6 +5284,9 @@
                     <a:bodyPr/>
                     <a:lstStyle/>
                     <a:p>
+                      <a:pPr>
+                        <a:defRPr sz="1000"/>
+                      </a:pPr>
                       <a:r>
                         <a:t>Other Civilizations</a:t>
                       </a:r>
@@ -4975,6 +5299,9 @@
                     <a:bodyPr/>
                     <a:lstStyle/>
                     <a:p>
+                      <a:pPr>
+                        <a:defRPr sz="1000"/>
+                      </a:pPr>
                       <a:r>
                         <a:t>d</a:t>
                       </a:r>
@@ -4987,6 +5314,9 @@
                     <a:bodyPr/>
                     <a:lstStyle/>
                     <a:p>
+                      <a:pPr>
+                        <a:defRPr sz="1000"/>
+                      </a:pPr>
                       <a:r>
                         <a:t>-2.125</a:t>
                       </a:r>
@@ -4999,6 +5329,9 @@
                     <a:bodyPr/>
                     <a:lstStyle/>
                     <a:p>
+                      <a:pPr>
+                        <a:defRPr sz="1000"/>
+                      </a:pPr>
                       <a:r>
                         <a:t>p_D</a:t>
                       </a:r>
@@ -5011,6 +5344,9 @@
                     <a:bodyPr/>
                     <a:lstStyle/>
                     <a:p>
+                      <a:pPr>
+                        <a:defRPr sz="1000"/>
+                      </a:pPr>
                       <a:r>
                         <a:t>0.094</a:t>
                       </a:r>
@@ -5023,6 +5359,9 @@
                     <a:bodyPr/>
                     <a:lstStyle/>
                     <a:p>
+                      <a:pPr>
+                        <a:defRPr sz="1000"/>
+                      </a:pPr>
                       <a:r>
                         <a:t>h_D</a:t>
                       </a:r>
@@ -5035,6 +5374,9 @@
                     <a:bodyPr/>
                     <a:lstStyle/>
                     <a:p>
+                      <a:pPr>
+                        <a:defRPr sz="1000"/>
+                      </a:pPr>
                       <a:r>
                         <a:t>0.047</a:t>
                       </a:r>
@@ -5049,6 +5391,9 @@
                     <a:bodyPr/>
                     <a:lstStyle/>
                     <a:p>
+                      <a:pPr>
+                        <a:defRPr sz="1000"/>
+                      </a:pPr>
                       <a:r>
                         <a:t>Other Western</a:t>
                       </a:r>
@@ -5061,6 +5406,9 @@
                     <a:bodyPr/>
                     <a:lstStyle/>
                     <a:p>
+                      <a:pPr>
+                        <a:defRPr sz="1000"/>
+                      </a:pPr>
                       <a:r>
                         <a:t>d</a:t>
                       </a:r>
@@ -5073,6 +5421,9 @@
                     <a:bodyPr/>
                     <a:lstStyle/>
                     <a:p>
+                      <a:pPr>
+                        <a:defRPr sz="1000"/>
+                      </a:pPr>
                       <a:r>
                         <a:t>-2.123</a:t>
                       </a:r>
@@ -5085,6 +5436,9 @@
                     <a:bodyPr/>
                     <a:lstStyle/>
                     <a:p>
+                      <a:pPr>
+                        <a:defRPr sz="1000"/>
+                      </a:pPr>
                       <a:r>
                         <a:t>p_D</a:t>
                       </a:r>
@@ -5097,6 +5451,9 @@
                     <a:bodyPr/>
                     <a:lstStyle/>
                     <a:p>
+                      <a:pPr>
+                        <a:defRPr sz="1000"/>
+                      </a:pPr>
                       <a:r>
                         <a:t>0.137</a:t>
                       </a:r>
@@ -5109,6 +5466,9 @@
                     <a:bodyPr/>
                     <a:lstStyle/>
                     <a:p>
+                      <a:pPr>
+                        <a:defRPr sz="1000"/>
+                      </a:pPr>
                       <a:r>
                         <a:t>h_D</a:t>
                       </a:r>
@@ -5121,6 +5481,9 @@
                     <a:bodyPr/>
                     <a:lstStyle/>
                     <a:p>
+                      <a:pPr>
+                        <a:defRPr sz="1000"/>
+                      </a:pPr>
                       <a:r>
                         <a:t>0.014</a:t>
                       </a:r>
@@ -5135,6 +5498,9 @@
                     <a:bodyPr/>
                     <a:lstStyle/>
                     <a:p>
+                      <a:pPr>
+                        <a:defRPr sz="1000"/>
+                      </a:pPr>
                       <a:r>
                         <a:t>Sinic</a:t>
                       </a:r>
@@ -5147,6 +5513,9 @@
                     <a:bodyPr/>
                     <a:lstStyle/>
                     <a:p>
+                      <a:pPr>
+                        <a:defRPr sz="1000"/>
+                      </a:pPr>
                       <a:r>
                         <a:t>d</a:t>
                       </a:r>
@@ -5159,6 +5528,9 @@
                     <a:bodyPr/>
                     <a:lstStyle/>
                     <a:p>
+                      <a:pPr>
+                        <a:defRPr sz="1000"/>
+                      </a:pPr>
                       <a:r>
                         <a:t>-2.027</a:t>
                       </a:r>
@@ -5171,6 +5543,9 @@
                     <a:bodyPr/>
                     <a:lstStyle/>
                     <a:p>
+                      <a:pPr>
+                        <a:defRPr sz="1000"/>
+                      </a:pPr>
                       <a:r>
                         <a:t>p_D</a:t>
                       </a:r>
@@ -5183,6 +5558,9 @@
                     <a:bodyPr/>
                     <a:lstStyle/>
                     <a:p>
+                      <a:pPr>
+                        <a:defRPr sz="1000"/>
+                      </a:pPr>
                       <a:r>
                         <a:t>0.035</a:t>
                       </a:r>
@@ -5195,6 +5573,9 @@
                     <a:bodyPr/>
                     <a:lstStyle/>
                     <a:p>
+                      <a:pPr>
+                        <a:defRPr sz="1000"/>
+                      </a:pPr>
                       <a:r>
                         <a:t>h_D</a:t>
                       </a:r>
@@ -5207,6 +5588,9 @@
                     <a:bodyPr/>
                     <a:lstStyle/>
                     <a:p>
+                      <a:pPr>
+                        <a:defRPr sz="1000"/>
+                      </a:pPr>
                       <a:r>
                         <a:t>0.021</a:t>
                       </a:r>
@@ -5221,6 +5605,9 @@
                     <a:bodyPr/>
                     <a:lstStyle/>
                     <a:p>
+                      <a:pPr>
+                        <a:defRPr sz="1000"/>
+                      </a:pPr>
                       <a:r>
                         <a:t>United States</a:t>
                       </a:r>
@@ -5233,6 +5620,9 @@
                     <a:bodyPr/>
                     <a:lstStyle/>
                     <a:p>
+                      <a:pPr>
+                        <a:defRPr sz="1000"/>
+                      </a:pPr>
                       <a:r>
                         <a:t>d</a:t>
                       </a:r>
@@ -5245,6 +5635,9 @@
                     <a:bodyPr/>
                     <a:lstStyle/>
                     <a:p>
+                      <a:pPr>
+                        <a:defRPr sz="1000"/>
+                      </a:pPr>
                       <a:r>
                         <a:t>-2.126</a:t>
                       </a:r>
@@ -5257,6 +5650,9 @@
                     <a:bodyPr/>
                     <a:lstStyle/>
                     <a:p>
+                      <a:pPr>
+                        <a:defRPr sz="1000"/>
+                      </a:pPr>
                       <a:r>
                         <a:t>p_D</a:t>
                       </a:r>
@@ -5269,6 +5665,9 @@
                     <a:bodyPr/>
                     <a:lstStyle/>
                     <a:p>
+                      <a:pPr>
+                        <a:defRPr sz="1000"/>
+                      </a:pPr>
                       <a:r>
                         <a:t>0.087</a:t>
                       </a:r>
@@ -5281,6 +5680,9 @@
                     <a:bodyPr/>
                     <a:lstStyle/>
                     <a:p>
+                      <a:pPr>
+                        <a:defRPr sz="1000"/>
+                      </a:pPr>
                       <a:r>
                         <a:t>h_D</a:t>
                       </a:r>
@@ -5293,6 +5695,9 @@
                     <a:bodyPr/>
                     <a:lstStyle/>
                     <a:p>
+                      <a:pPr>
+                        <a:defRPr sz="1000"/>
+                      </a:pPr>
                       <a:r>
                         <a:t>0.066</a:t>
                       </a:r>
@@ -5450,6 +5855,9 @@
                     <a:bodyPr/>
                     <a:lstStyle/>
                     <a:p>
+                      <a:pPr>
+                        <a:defRPr sz="1000"/>
+                      </a:pPr>
                       <a:r>
                         <a:t>Japanese</a:t>
                       </a:r>
@@ -5462,6 +5870,9 @@
                     <a:bodyPr/>
                     <a:lstStyle/>
                     <a:p>
+                      <a:pPr>
+                        <a:defRPr sz="1000"/>
+                      </a:pPr>
                       <a:r>
                         <a:t>domestic_PIs</a:t>
                       </a:r>
@@ -5474,6 +5885,9 @@
                     <a:bodyPr/>
                     <a:lstStyle/>
                     <a:p>
+                      <a:pPr>
+                        <a:defRPr sz="1000"/>
+                      </a:pPr>
                       <a:r>
                         <a:t>d</a:t>
                       </a:r>
@@ -5486,32 +5900,41 @@
                     <a:bodyPr/>
                     <a:lstStyle/>
                     <a:p>
-                      <a:r>
-                        <a:t>0.01</a:t>
-                      </a:r>
-                    </a:p>
-                  </a:txBody>
-                  <a:tcPr/>
-                </a:tc>
-                <a:tc>
-                  <a:txBody>
-                    <a:bodyPr/>
-                    <a:lstStyle/>
-                    <a:p>
-                      <a:r>
-                        <a:t>1.58</a:t>
-                      </a:r>
-                    </a:p>
-                  </a:txBody>
-                  <a:tcPr/>
-                </a:tc>
-                <a:tc>
-                  <a:txBody>
-                    <a:bodyPr/>
-                    <a:lstStyle/>
-                    <a:p>
-                      <a:r>
-                        <a:t>0.58</a:t>
+                      <a:pPr>
+                        <a:defRPr sz="1000"/>
+                      </a:pPr>
+                      <a:r>
+                        <a:t>0.0134</a:t>
+                      </a:r>
+                    </a:p>
+                  </a:txBody>
+                  <a:tcPr/>
+                </a:tc>
+                <a:tc>
+                  <a:txBody>
+                    <a:bodyPr/>
+                    <a:lstStyle/>
+                    <a:p>
+                      <a:pPr>
+                        <a:defRPr sz="1000"/>
+                      </a:pPr>
+                      <a:r>
+                        <a:t>1.580</a:t>
+                      </a:r>
+                    </a:p>
+                  </a:txBody>
+                  <a:tcPr/>
+                </a:tc>
+                <a:tc>
+                  <a:txBody>
+                    <a:bodyPr/>
+                    <a:lstStyle/>
+                    <a:p>
+                      <a:pPr>
+                        <a:defRPr sz="1000"/>
+                      </a:pPr>
+                      <a:r>
+                        <a:t>0.580</a:t>
                       </a:r>
                     </a:p>
                   </a:txBody>
@@ -5524,6 +5947,9 @@
                     <a:bodyPr/>
                     <a:lstStyle/>
                     <a:p>
+                      <a:pPr>
+                        <a:defRPr sz="1000"/>
+                      </a:pPr>
                       <a:r>
                         <a:t>Other Civilizations</a:t>
                       </a:r>
@@ -5536,6 +5962,9 @@
                     <a:bodyPr/>
                     <a:lstStyle/>
                     <a:p>
+                      <a:pPr>
+                        <a:defRPr sz="1000"/>
+                      </a:pPr>
                       <a:r>
                         <a:t>domestic_PIs</a:t>
                       </a:r>
@@ -5548,6 +5977,9 @@
                     <a:bodyPr/>
                     <a:lstStyle/>
                     <a:p>
+                      <a:pPr>
+                        <a:defRPr sz="1000"/>
+                      </a:pPr>
                       <a:r>
                         <a:t>I0</a:t>
                       </a:r>
@@ -5560,32 +5992,41 @@
                     <a:bodyPr/>
                     <a:lstStyle/>
                     <a:p>
-                      <a:r>
-                        <a:t>1.15</a:t>
-                      </a:r>
-                    </a:p>
-                  </a:txBody>
-                  <a:tcPr/>
-                </a:tc>
-                <a:tc>
-                  <a:txBody>
-                    <a:bodyPr/>
-                    <a:lstStyle/>
-                    <a:p>
-                      <a:r>
-                        <a:t>0.28</a:t>
-                      </a:r>
-                    </a:p>
-                  </a:txBody>
-                  <a:tcPr/>
-                </a:tc>
-                <a:tc>
-                  <a:txBody>
-                    <a:bodyPr/>
-                    <a:lstStyle/>
-                    <a:p>
-                      <a:r>
-                        <a:t>0.72</a:t>
+                      <a:pPr>
+                        <a:defRPr sz="1000"/>
+                      </a:pPr>
+                      <a:r>
+                        <a:t>1.1486</a:t>
+                      </a:r>
+                    </a:p>
+                  </a:txBody>
+                  <a:tcPr/>
+                </a:tc>
+                <a:tc>
+                  <a:txBody>
+                    <a:bodyPr/>
+                    <a:lstStyle/>
+                    <a:p>
+                      <a:pPr>
+                        <a:defRPr sz="1000"/>
+                      </a:pPr>
+                      <a:r>
+                        <a:t>0.282</a:t>
+                      </a:r>
+                    </a:p>
+                  </a:txBody>
+                  <a:tcPr/>
+                </a:tc>
+                <a:tc>
+                  <a:txBody>
+                    <a:bodyPr/>
+                    <a:lstStyle/>
+                    <a:p>
+                      <a:pPr>
+                        <a:defRPr sz="1000"/>
+                      </a:pPr>
+                      <a:r>
+                        <a:t>0.718</a:t>
                       </a:r>
                     </a:p>
                   </a:txBody>
@@ -5598,6 +6039,9 @@
                     <a:bodyPr/>
                     <a:lstStyle/>
                     <a:p>
+                      <a:pPr>
+                        <a:defRPr sz="1000"/>
+                      </a:pPr>
                       <a:r>
                         <a:t>United States</a:t>
                       </a:r>
@@ -5610,6 +6054,9 @@
                     <a:bodyPr/>
                     <a:lstStyle/>
                     <a:p>
+                      <a:pPr>
+                        <a:defRPr sz="1000"/>
+                      </a:pPr>
                       <a:r>
                         <a:t>domestic_PIs</a:t>
                       </a:r>
@@ -5622,6 +6069,9 @@
                     <a:bodyPr/>
                     <a:lstStyle/>
                     <a:p>
+                      <a:pPr>
+                        <a:defRPr sz="1000"/>
+                      </a:pPr>
                       <a:r>
                         <a:t>I0</a:t>
                       </a:r>
@@ -5634,32 +6084,41 @@
                     <a:bodyPr/>
                     <a:lstStyle/>
                     <a:p>
-                      <a:r>
-                        <a:t>2.83</a:t>
-                      </a:r>
-                    </a:p>
-                  </a:txBody>
-                  <a:tcPr/>
-                </a:tc>
-                <a:tc>
-                  <a:txBody>
-                    <a:bodyPr/>
-                    <a:lstStyle/>
-                    <a:p>
-                      <a:r>
-                        <a:t>0.19</a:t>
-                      </a:r>
-                    </a:p>
-                  </a:txBody>
-                  <a:tcPr/>
-                </a:tc>
-                <a:tc>
-                  <a:txBody>
-                    <a:bodyPr/>
-                    <a:lstStyle/>
-                    <a:p>
-                      <a:r>
-                        <a:t>0.81</a:t>
+                      <a:pPr>
+                        <a:defRPr sz="1000"/>
+                      </a:pPr>
+                      <a:r>
+                        <a:t>2.8304</a:t>
+                      </a:r>
+                    </a:p>
+                  </a:txBody>
+                  <a:tcPr/>
+                </a:tc>
+                <a:tc>
+                  <a:txBody>
+                    <a:bodyPr/>
+                    <a:lstStyle/>
+                    <a:p>
+                      <a:pPr>
+                        <a:defRPr sz="1000"/>
+                      </a:pPr>
+                      <a:r>
+                        <a:t>0.185</a:t>
+                      </a:r>
+                    </a:p>
+                  </a:txBody>
+                  <a:tcPr/>
+                </a:tc>
+                <a:tc>
+                  <a:txBody>
+                    <a:bodyPr/>
+                    <a:lstStyle/>
+                    <a:p>
+                      <a:pPr>
+                        <a:defRPr sz="1000"/>
+                      </a:pPr>
+                      <a:r>
+                        <a:t>0.815</a:t>
                       </a:r>
                     </a:p>
                   </a:txBody>
@@ -5672,6 +6131,9 @@
                     <a:bodyPr/>
                     <a:lstStyle/>
                     <a:p>
+                      <a:pPr>
+                        <a:defRPr sz="1000"/>
+                      </a:pPr>
                       <a:r>
                         <a:t>Anglosphere ex-US</a:t>
                       </a:r>
@@ -5684,6 +6146,9 @@
                     <a:bodyPr/>
                     <a:lstStyle/>
                     <a:p>
+                      <a:pPr>
+                        <a:defRPr sz="1000"/>
+                      </a:pPr>
                       <a:r>
                         <a:t>domestic_PIs</a:t>
                       </a:r>
@@ -5696,6 +6161,9 @@
                     <a:bodyPr/>
                     <a:lstStyle/>
                     <a:p>
+                      <a:pPr>
+                        <a:defRPr sz="1000"/>
+                      </a:pPr>
                       <a:r>
                         <a:t>I0</a:t>
                       </a:r>
@@ -5708,32 +6176,41 @@
                     <a:bodyPr/>
                     <a:lstStyle/>
                     <a:p>
-                      <a:r>
-                        <a:t>1.55</a:t>
-                      </a:r>
-                    </a:p>
-                  </a:txBody>
-                  <a:tcPr/>
-                </a:tc>
-                <a:tc>
-                  <a:txBody>
-                    <a:bodyPr/>
-                    <a:lstStyle/>
-                    <a:p>
-                      <a:r>
-                        <a:t>0.18</a:t>
-                      </a:r>
-                    </a:p>
-                  </a:txBody>
-                  <a:tcPr/>
-                </a:tc>
-                <a:tc>
-                  <a:txBody>
-                    <a:bodyPr/>
-                    <a:lstStyle/>
-                    <a:p>
-                      <a:r>
-                        <a:t>0.82</a:t>
+                      <a:pPr>
+                        <a:defRPr sz="1000"/>
+                      </a:pPr>
+                      <a:r>
+                        <a:t>1.5548</a:t>
+                      </a:r>
+                    </a:p>
+                  </a:txBody>
+                  <a:tcPr/>
+                </a:tc>
+                <a:tc>
+                  <a:txBody>
+                    <a:bodyPr/>
+                    <a:lstStyle/>
+                    <a:p>
+                      <a:pPr>
+                        <a:defRPr sz="1000"/>
+                      </a:pPr>
+                      <a:r>
+                        <a:t>0.184</a:t>
+                      </a:r>
+                    </a:p>
+                  </a:txBody>
+                  <a:tcPr/>
+                </a:tc>
+                <a:tc>
+                  <a:txBody>
+                    <a:bodyPr/>
+                    <a:lstStyle/>
+                    <a:p>
+                      <a:pPr>
+                        <a:defRPr sz="1000"/>
+                      </a:pPr>
+                      <a:r>
+                        <a:t>0.816</a:t>
                       </a:r>
                     </a:p>
                   </a:txBody>
@@ -5746,6 +6223,9 @@
                     <a:bodyPr/>
                     <a:lstStyle/>
                     <a:p>
+                      <a:pPr>
+                        <a:defRPr sz="1000"/>
+                      </a:pPr>
                       <a:r>
                         <a:t>Islamic</a:t>
                       </a:r>
@@ -5758,6 +6238,9 @@
                     <a:bodyPr/>
                     <a:lstStyle/>
                     <a:p>
+                      <a:pPr>
+                        <a:defRPr sz="1000"/>
+                      </a:pPr>
                       <a:r>
                         <a:t>domestic_PIs</a:t>
                       </a:r>
@@ -5770,6 +6253,9 @@
                     <a:bodyPr/>
                     <a:lstStyle/>
                     <a:p>
+                      <a:pPr>
+                        <a:defRPr sz="1000"/>
+                      </a:pPr>
                       <a:r>
                         <a:t>I0</a:t>
                       </a:r>
@@ -5782,32 +6268,41 @@
                     <a:bodyPr/>
                     <a:lstStyle/>
                     <a:p>
-                      <a:r>
-                        <a:t>1.16</a:t>
-                      </a:r>
-                    </a:p>
-                  </a:txBody>
-                  <a:tcPr/>
-                </a:tc>
-                <a:tc>
-                  <a:txBody>
-                    <a:bodyPr/>
-                    <a:lstStyle/>
-                    <a:p>
-                      <a:r>
-                        <a:t>0.15</a:t>
-                      </a:r>
-                    </a:p>
-                  </a:txBody>
-                  <a:tcPr/>
-                </a:tc>
-                <a:tc>
-                  <a:txBody>
-                    <a:bodyPr/>
-                    <a:lstStyle/>
-                    <a:p>
-                      <a:r>
-                        <a:t>0.85</a:t>
+                      <a:pPr>
+                        <a:defRPr sz="1000"/>
+                      </a:pPr>
+                      <a:r>
+                        <a:t>1.1638</a:t>
+                      </a:r>
+                    </a:p>
+                  </a:txBody>
+                  <a:tcPr/>
+                </a:tc>
+                <a:tc>
+                  <a:txBody>
+                    <a:bodyPr/>
+                    <a:lstStyle/>
+                    <a:p>
+                      <a:pPr>
+                        <a:defRPr sz="1000"/>
+                      </a:pPr>
+                      <a:r>
+                        <a:t>0.153</a:t>
+                      </a:r>
+                    </a:p>
+                  </a:txBody>
+                  <a:tcPr/>
+                </a:tc>
+                <a:tc>
+                  <a:txBody>
+                    <a:bodyPr/>
+                    <a:lstStyle/>
+                    <a:p>
+                      <a:pPr>
+                        <a:defRPr sz="1000"/>
+                      </a:pPr>
+                      <a:r>
+                        <a:t>0.847</a:t>
                       </a:r>
                     </a:p>
                   </a:txBody>
@@ -5820,6 +6315,9 @@
                     <a:bodyPr/>
                     <a:lstStyle/>
                     <a:p>
+                      <a:pPr>
+                        <a:defRPr sz="1000"/>
+                      </a:pPr>
                       <a:r>
                         <a:t>Other Western</a:t>
                       </a:r>
@@ -5832,6 +6330,9 @@
                     <a:bodyPr/>
                     <a:lstStyle/>
                     <a:p>
+                      <a:pPr>
+                        <a:defRPr sz="1000"/>
+                      </a:pPr>
                       <a:r>
                         <a:t>domestic_PIs</a:t>
                       </a:r>
@@ -5844,6 +6345,9 @@
                     <a:bodyPr/>
                     <a:lstStyle/>
                     <a:p>
+                      <a:pPr>
+                        <a:defRPr sz="1000"/>
+                      </a:pPr>
                       <a:r>
                         <a:t>I0</a:t>
                       </a:r>
@@ -5856,32 +6360,41 @@
                     <a:bodyPr/>
                     <a:lstStyle/>
                     <a:p>
-                      <a:r>
-                        <a:t>0.87</a:t>
-                      </a:r>
-                    </a:p>
-                  </a:txBody>
-                  <a:tcPr/>
-                </a:tc>
-                <a:tc>
-                  <a:txBody>
-                    <a:bodyPr/>
-                    <a:lstStyle/>
-                    <a:p>
-                      <a:r>
-                        <a:t>0.13</a:t>
-                      </a:r>
-                    </a:p>
-                  </a:txBody>
-                  <a:tcPr/>
-                </a:tc>
-                <a:tc>
-                  <a:txBody>
-                    <a:bodyPr/>
-                    <a:lstStyle/>
-                    <a:p>
-                      <a:r>
-                        <a:t>0.87</a:t>
+                      <a:pPr>
+                        <a:defRPr sz="1000"/>
+                      </a:pPr>
+                      <a:r>
+                        <a:t>0.8723</a:t>
+                      </a:r>
+                    </a:p>
+                  </a:txBody>
+                  <a:tcPr/>
+                </a:tc>
+                <a:tc>
+                  <a:txBody>
+                    <a:bodyPr/>
+                    <a:lstStyle/>
+                    <a:p>
+                      <a:pPr>
+                        <a:defRPr sz="1000"/>
+                      </a:pPr>
+                      <a:r>
+                        <a:t>0.131</a:t>
+                      </a:r>
+                    </a:p>
+                  </a:txBody>
+                  <a:tcPr/>
+                </a:tc>
+                <a:tc>
+                  <a:txBody>
+                    <a:bodyPr/>
+                    <a:lstStyle/>
+                    <a:p>
+                      <a:pPr>
+                        <a:defRPr sz="1000"/>
+                      </a:pPr>
+                      <a:r>
+                        <a:t>0.869</a:t>
                       </a:r>
                     </a:p>
                   </a:txBody>
@@ -5894,6 +6407,9 @@
                     <a:bodyPr/>
                     <a:lstStyle/>
                     <a:p>
+                      <a:pPr>
+                        <a:defRPr sz="1000"/>
+                      </a:pPr>
                       <a:r>
                         <a:t>Continental Europe</a:t>
                       </a:r>
@@ -5906,6 +6422,9 @@
                     <a:bodyPr/>
                     <a:lstStyle/>
                     <a:p>
+                      <a:pPr>
+                        <a:defRPr sz="1000"/>
+                      </a:pPr>
                       <a:r>
                         <a:t>domestic_PIs</a:t>
                       </a:r>
@@ -5918,6 +6437,9 @@
                     <a:bodyPr/>
                     <a:lstStyle/>
                     <a:p>
+                      <a:pPr>
+                        <a:defRPr sz="1000"/>
+                      </a:pPr>
                       <a:r>
                         <a:t>I0</a:t>
                       </a:r>
@@ -5930,32 +6452,41 @@
                     <a:bodyPr/>
                     <a:lstStyle/>
                     <a:p>
-                      <a:r>
-                        <a:t>2.76</a:t>
-                      </a:r>
-                    </a:p>
-                  </a:txBody>
-                  <a:tcPr/>
-                </a:tc>
-                <a:tc>
-                  <a:txBody>
-                    <a:bodyPr/>
-                    <a:lstStyle/>
-                    <a:p>
-                      <a:r>
-                        <a:t>0.12</a:t>
-                      </a:r>
-                    </a:p>
-                  </a:txBody>
-                  <a:tcPr/>
-                </a:tc>
-                <a:tc>
-                  <a:txBody>
-                    <a:bodyPr/>
-                    <a:lstStyle/>
-                    <a:p>
-                      <a:r>
-                        <a:t>0.88</a:t>
+                      <a:pPr>
+                        <a:defRPr sz="1000"/>
+                      </a:pPr>
+                      <a:r>
+                        <a:t>2.7634</a:t>
+                      </a:r>
+                    </a:p>
+                  </a:txBody>
+                  <a:tcPr/>
+                </a:tc>
+                <a:tc>
+                  <a:txBody>
+                    <a:bodyPr/>
+                    <a:lstStyle/>
+                    <a:p>
+                      <a:pPr>
+                        <a:defRPr sz="1000"/>
+                      </a:pPr>
+                      <a:r>
+                        <a:t>0.122</a:t>
+                      </a:r>
+                    </a:p>
+                  </a:txBody>
+                  <a:tcPr/>
+                </a:tc>
+                <a:tc>
+                  <a:txBody>
+                    <a:bodyPr/>
+                    <a:lstStyle/>
+                    <a:p>
+                      <a:pPr>
+                        <a:defRPr sz="1000"/>
+                      </a:pPr>
+                      <a:r>
+                        <a:t>0.878</a:t>
                       </a:r>
                     </a:p>
                   </a:txBody>
@@ -5968,6 +6499,9 @@
                     <a:bodyPr/>
                     <a:lstStyle/>
                     <a:p>
+                      <a:pPr>
+                        <a:defRPr sz="1000"/>
+                      </a:pPr>
                       <a:r>
                         <a:t>Sinic</a:t>
                       </a:r>
@@ -5980,6 +6514,9 @@
                     <a:bodyPr/>
                     <a:lstStyle/>
                     <a:p>
+                      <a:pPr>
+                        <a:defRPr sz="1000"/>
+                      </a:pPr>
                       <a:r>
                         <a:t>domestic_PIs</a:t>
                       </a:r>
@@ -5992,6 +6529,9 @@
                     <a:bodyPr/>
                     <a:lstStyle/>
                     <a:p>
+                      <a:pPr>
+                        <a:defRPr sz="1000"/>
+                      </a:pPr>
                       <a:r>
                         <a:t>I0</a:t>
                       </a:r>
@@ -6004,32 +6544,41 @@
                     <a:bodyPr/>
                     <a:lstStyle/>
                     <a:p>
-                      <a:r>
-                        <a:t>2.38</a:t>
-                      </a:r>
-                    </a:p>
-                  </a:txBody>
-                  <a:tcPr/>
-                </a:tc>
-                <a:tc>
-                  <a:txBody>
-                    <a:bodyPr/>
-                    <a:lstStyle/>
-                    <a:p>
-                      <a:r>
-                        <a:t>0.07</a:t>
-                      </a:r>
-                    </a:p>
-                  </a:txBody>
-                  <a:tcPr/>
-                </a:tc>
-                <a:tc>
-                  <a:txBody>
-                    <a:bodyPr/>
-                    <a:lstStyle/>
-                    <a:p>
-                      <a:r>
-                        <a:t>0.93</a:t>
+                      <a:pPr>
+                        <a:defRPr sz="1000"/>
+                      </a:pPr>
+                      <a:r>
+                        <a:t>2.3837</a:t>
+                      </a:r>
+                    </a:p>
+                  </a:txBody>
+                  <a:tcPr/>
+                </a:tc>
+                <a:tc>
+                  <a:txBody>
+                    <a:bodyPr/>
+                    <a:lstStyle/>
+                    <a:p>
+                      <a:pPr>
+                        <a:defRPr sz="1000"/>
+                      </a:pPr>
+                      <a:r>
+                        <a:t>0.066</a:t>
+                      </a:r>
+                    </a:p>
+                  </a:txBody>
+                  <a:tcPr/>
+                </a:tc>
+                <a:tc>
+                  <a:txBody>
+                    <a:bodyPr/>
+                    <a:lstStyle/>
+                    <a:p>
+                      <a:pPr>
+                        <a:defRPr sz="1000"/>
+                      </a:pPr>
+                      <a:r>
+                        <a:t>0.934</a:t>
                       </a:r>
                     </a:p>
                   </a:txBody>
@@ -6042,6 +6591,9 @@
                     <a:bodyPr/>
                     <a:lstStyle/>
                     <a:p>
+                      <a:pPr>
+                        <a:defRPr sz="1000"/>
+                      </a:pPr>
                       <a:r>
                         <a:t>Hindu</a:t>
                       </a:r>
@@ -6054,6 +6606,9 @@
                     <a:bodyPr/>
                     <a:lstStyle/>
                     <a:p>
+                      <a:pPr>
+                        <a:defRPr sz="1000"/>
+                      </a:pPr>
                       <a:r>
                         <a:t>domestic_PIs</a:t>
                       </a:r>
@@ -6066,6 +6621,9 @@
                     <a:bodyPr/>
                     <a:lstStyle/>
                     <a:p>
+                      <a:pPr>
+                        <a:defRPr sz="1000"/>
+                      </a:pPr>
                       <a:r>
                         <a:t>I0</a:t>
                       </a:r>
@@ -6078,32 +6636,41 @@
                     <a:bodyPr/>
                     <a:lstStyle/>
                     <a:p>
-                      <a:r>
-                        <a:t>1.52</a:t>
-                      </a:r>
-                    </a:p>
-                  </a:txBody>
-                  <a:tcPr/>
-                </a:tc>
-                <a:tc>
-                  <a:txBody>
-                    <a:bodyPr/>
-                    <a:lstStyle/>
-                    <a:p>
-                      <a:r>
-                        <a:t>0.05</a:t>
-                      </a:r>
-                    </a:p>
-                  </a:txBody>
-                  <a:tcPr/>
-                </a:tc>
-                <a:tc>
-                  <a:txBody>
-                    <a:bodyPr/>
-                    <a:lstStyle/>
-                    <a:p>
-                      <a:r>
-                        <a:t>0.95</a:t>
+                      <a:pPr>
+                        <a:defRPr sz="1000"/>
+                      </a:pPr>
+                      <a:r>
+                        <a:t>1.5156</a:t>
+                      </a:r>
+                    </a:p>
+                  </a:txBody>
+                  <a:tcPr/>
+                </a:tc>
+                <a:tc>
+                  <a:txBody>
+                    <a:bodyPr/>
+                    <a:lstStyle/>
+                    <a:p>
+                      <a:pPr>
+                        <a:defRPr sz="1000"/>
+                      </a:pPr>
+                      <a:r>
+                        <a:t>0.046</a:t>
+                      </a:r>
+                    </a:p>
+                  </a:txBody>
+                  <a:tcPr/>
+                </a:tc>
+                <a:tc>
+                  <a:txBody>
+                    <a:bodyPr/>
+                    <a:lstStyle/>
+                    <a:p>
+                      <a:pPr>
+                        <a:defRPr sz="1000"/>
+                      </a:pPr>
+                      <a:r>
+                        <a:t>0.954</a:t>
                       </a:r>
                     </a:p>
                   </a:txBody>
@@ -6233,6 +6800,9 @@
                     <a:bodyPr/>
                     <a:lstStyle/>
                     <a:p>
+                      <a:pPr>
+                        <a:defRPr sz="1000"/>
+                      </a:pPr>
                       <a:r>
                         <a:t>Anglosphere ex-US</a:t>
                       </a:r>
@@ -6245,6 +6815,9 @@
                     <a:bodyPr/>
                     <a:lstStyle/>
                     <a:p>
+                      <a:pPr>
+                        <a:defRPr sz="1000"/>
+                      </a:pPr>
                       <a:r>
                         <a:t>752.12</a:t>
                       </a:r>
@@ -6257,6 +6830,9 @@
                     <a:bodyPr/>
                     <a:lstStyle/>
                     <a:p>
+                      <a:pPr>
+                        <a:defRPr sz="1000"/>
+                      </a:pPr>
                       <a:r>
                         <a:t>411.20</a:t>
                       </a:r>
@@ -6269,8 +6845,11 @@
                     <a:bodyPr/>
                     <a:lstStyle/>
                     <a:p>
-                      <a:r>
-                        <a:t>0.01</a:t>
+                      <a:pPr>
+                        <a:defRPr sz="1000"/>
+                      </a:pPr>
+                      <a:r>
+                        <a:t>0.01429</a:t>
                       </a:r>
                     </a:p>
                   </a:txBody>
@@ -6283,6 +6862,9 @@
                     <a:bodyPr/>
                     <a:lstStyle/>
                     <a:p>
+                      <a:pPr>
+                        <a:defRPr sz="1000"/>
+                      </a:pPr>
                       <a:r>
                         <a:t>Continental Europe</a:t>
                       </a:r>
@@ -6295,6 +6877,9 @@
                     <a:bodyPr/>
                     <a:lstStyle/>
                     <a:p>
+                      <a:pPr>
+                        <a:defRPr sz="1000"/>
+                      </a:pPr>
                       <a:r>
                         <a:t>1156.27</a:t>
                       </a:r>
@@ -6307,6 +6892,9 @@
                     <a:bodyPr/>
                     <a:lstStyle/>
                     <a:p>
+                      <a:pPr>
+                        <a:defRPr sz="1000"/>
+                      </a:pPr>
                       <a:r>
                         <a:t>632.67</a:t>
                       </a:r>
@@ -6319,8 +6907,11 @@
                     <a:bodyPr/>
                     <a:lstStyle/>
                     <a:p>
-                      <a:r>
-                        <a:t>0.01</a:t>
+                      <a:pPr>
+                        <a:defRPr sz="1000"/>
+                      </a:pPr>
+                      <a:r>
+                        <a:t>0.00870</a:t>
                       </a:r>
                     </a:p>
                   </a:txBody>
@@ -6333,6 +6924,9 @@
                     <a:bodyPr/>
                     <a:lstStyle/>
                     <a:p>
+                      <a:pPr>
+                        <a:defRPr sz="1000"/>
+                      </a:pPr>
                       <a:r>
                         <a:t>Hindu</a:t>
                       </a:r>
@@ -6345,6 +6939,9 @@
                     <a:bodyPr/>
                     <a:lstStyle/>
                     <a:p>
+                      <a:pPr>
+                        <a:defRPr sz="1000"/>
+                      </a:pPr>
                       <a:r>
                         <a:t>1497.37</a:t>
                       </a:r>
@@ -6357,6 +6954,9 @@
                     <a:bodyPr/>
                     <a:lstStyle/>
                     <a:p>
+                      <a:pPr>
+                        <a:defRPr sz="1000"/>
+                      </a:pPr>
                       <a:r>
                         <a:t>781.23</a:t>
                       </a:r>
@@ -6369,8 +6969,11 @@
                     <a:bodyPr/>
                     <a:lstStyle/>
                     <a:p>
-                      <a:r>
-                        <a:t>0.02</a:t>
+                      <a:pPr>
+                        <a:defRPr sz="1000"/>
+                      </a:pPr>
+                      <a:r>
+                        <a:t>0.01538</a:t>
                       </a:r>
                     </a:p>
                   </a:txBody>
@@ -6383,6 +6986,9 @@
                     <a:bodyPr/>
                     <a:lstStyle/>
                     <a:p>
+                      <a:pPr>
+                        <a:defRPr sz="1000"/>
+                      </a:pPr>
                       <a:r>
                         <a:t>Islamic</a:t>
                       </a:r>
@@ -6395,6 +7001,9 @@
                     <a:bodyPr/>
                     <a:lstStyle/>
                     <a:p>
+                      <a:pPr>
+                        <a:defRPr sz="1000"/>
+                      </a:pPr>
                       <a:r>
                         <a:t>892.42</a:t>
                       </a:r>
@@ -6407,6 +7016,9 @@
                     <a:bodyPr/>
                     <a:lstStyle/>
                     <a:p>
+                      <a:pPr>
+                        <a:defRPr sz="1000"/>
+                      </a:pPr>
                       <a:r>
                         <a:t>469.06</a:t>
                       </a:r>
@@ -6419,8 +7031,11 @@
                     <a:bodyPr/>
                     <a:lstStyle/>
                     <a:p>
-                      <a:r>
-                        <a:t>0.02</a:t>
+                      <a:pPr>
+                        <a:defRPr sz="1000"/>
+                      </a:pPr>
+                      <a:r>
+                        <a:t>0.02222</a:t>
                       </a:r>
                     </a:p>
                   </a:txBody>
@@ -6433,6 +7048,9 @@
                     <a:bodyPr/>
                     <a:lstStyle/>
                     <a:p>
+                      <a:pPr>
+                        <a:defRPr sz="1000"/>
+                      </a:pPr>
                       <a:r>
                         <a:t>Japanese</a:t>
                       </a:r>
@@ -6445,6 +7063,9 @@
                     <a:bodyPr/>
                     <a:lstStyle/>
                     <a:p>
+                      <a:pPr>
+                        <a:defRPr sz="1000"/>
+                      </a:pPr>
                       <a:r>
                         <a:t>206.81</a:t>
                       </a:r>
@@ -6457,6 +7078,9 @@
                     <a:bodyPr/>
                     <a:lstStyle/>
                     <a:p>
+                      <a:pPr>
+                        <a:defRPr sz="1000"/>
+                      </a:pPr>
                       <a:r>
                         <a:t>129.35</a:t>
                       </a:r>
@@ -6469,8 +7093,11 @@
                     <a:bodyPr/>
                     <a:lstStyle/>
                     <a:p>
-                      <a:r>
-                        <a:t>0.02</a:t>
+                      <a:pPr>
+                        <a:defRPr sz="1000"/>
+                      </a:pPr>
+                      <a:r>
+                        <a:t>0.01818</a:t>
                       </a:r>
                     </a:p>
                   </a:txBody>
@@ -6483,6 +7110,9 @@
                     <a:bodyPr/>
                     <a:lstStyle/>
                     <a:p>
+                      <a:pPr>
+                        <a:defRPr sz="1000"/>
+                      </a:pPr>
                       <a:r>
                         <a:t>Other Civilizations</a:t>
                       </a:r>
@@ -6495,6 +7125,9 @@
                     <a:bodyPr/>
                     <a:lstStyle/>
                     <a:p>
+                      <a:pPr>
+                        <a:defRPr sz="1000"/>
+                      </a:pPr>
                       <a:r>
                         <a:t>424.70</a:t>
                       </a:r>
@@ -6507,6 +7140,9 @@
                     <a:bodyPr/>
                     <a:lstStyle/>
                     <a:p>
+                      <a:pPr>
+                        <a:defRPr sz="1000"/>
+                      </a:pPr>
                       <a:r>
                         <a:t>234.34</a:t>
                       </a:r>
@@ -6519,8 +7155,11 @@
                     <a:bodyPr/>
                     <a:lstStyle/>
                     <a:p>
-                      <a:r>
-                        <a:t>0.02</a:t>
+                      <a:pPr>
+                        <a:defRPr sz="1000"/>
+                      </a:pPr>
+                      <a:r>
+                        <a:t>0.02222</a:t>
                       </a:r>
                     </a:p>
                   </a:txBody>
@@ -6533,6 +7172,9 @@
                     <a:bodyPr/>
                     <a:lstStyle/>
                     <a:p>
+                      <a:pPr>
+                        <a:defRPr sz="1000"/>
+                      </a:pPr>
                       <a:r>
                         <a:t>Other Western</a:t>
                       </a:r>
@@ -6545,6 +7187,9 @@
                     <a:bodyPr/>
                     <a:lstStyle/>
                     <a:p>
+                      <a:pPr>
+                        <a:defRPr sz="1000"/>
+                      </a:pPr>
                       <a:r>
                         <a:t>513.12</a:t>
                       </a:r>
@@ -6557,6 +7202,9 @@
                     <a:bodyPr/>
                     <a:lstStyle/>
                     <a:p>
+                      <a:pPr>
+                        <a:defRPr sz="1000"/>
+                      </a:pPr>
                       <a:r>
                         <a:t>270.32</a:t>
                       </a:r>
@@ -6569,8 +7217,11 @@
                     <a:bodyPr/>
                     <a:lstStyle/>
                     <a:p>
-                      <a:r>
-                        <a:t>0.04</a:t>
+                      <a:pPr>
+                        <a:defRPr sz="1000"/>
+                      </a:pPr>
+                      <a:r>
+                        <a:t>0.04000</a:t>
                       </a:r>
                     </a:p>
                   </a:txBody>
@@ -6583,6 +7234,9 @@
                     <a:bodyPr/>
                     <a:lstStyle/>
                     <a:p>
+                      <a:pPr>
+                        <a:defRPr sz="1000"/>
+                      </a:pPr>
                       <a:r>
                         <a:t>Sinic</a:t>
                       </a:r>
@@ -6595,6 +7249,9 @@
                     <a:bodyPr/>
                     <a:lstStyle/>
                     <a:p>
+                      <a:pPr>
+                        <a:defRPr sz="1000"/>
+                      </a:pPr>
                       <a:r>
                         <a:t>1783.64</a:t>
                       </a:r>
@@ -6607,6 +7264,9 @@
                     <a:bodyPr/>
                     <a:lstStyle/>
                     <a:p>
+                      <a:pPr>
+                        <a:defRPr sz="1000"/>
+                      </a:pPr>
                       <a:r>
                         <a:t>940.82</a:t>
                       </a:r>
@@ -6619,8 +7279,11 @@
                     <a:bodyPr/>
                     <a:lstStyle/>
                     <a:p>
-                      <a:r>
-                        <a:t>0.01</a:t>
+                      <a:pPr>
+                        <a:defRPr sz="1000"/>
+                      </a:pPr>
+                      <a:r>
+                        <a:t>0.01000</a:t>
                       </a:r>
                     </a:p>
                   </a:txBody>
@@ -6633,6 +7296,9 @@
                     <a:bodyPr/>
                     <a:lstStyle/>
                     <a:p>
+                      <a:pPr>
+                        <a:defRPr sz="1000"/>
+                      </a:pPr>
                       <a:r>
                         <a:t>United States</a:t>
                       </a:r>
@@ -6645,6 +7311,9 @@
                     <a:bodyPr/>
                     <a:lstStyle/>
                     <a:p>
+                      <a:pPr>
+                        <a:defRPr sz="1000"/>
+                      </a:pPr>
                       <a:r>
                         <a:t>801.70</a:t>
                       </a:r>
@@ -6657,6 +7326,9 @@
                     <a:bodyPr/>
                     <a:lstStyle/>
                     <a:p>
+                      <a:pPr>
+                        <a:defRPr sz="1000"/>
+                      </a:pPr>
                       <a:r>
                         <a:t>462.03</a:t>
                       </a:r>
@@ -6669,8 +7341,11 @@
                     <a:bodyPr/>
                     <a:lstStyle/>
                     <a:p>
-                      <a:r>
-                        <a:t>0.01</a:t>
+                      <a:pPr>
+                        <a:defRPr sz="1000"/>
+                      </a:pPr>
+                      <a:r>
+                        <a:t>0.00714</a:t>
                       </a:r>
                     </a:p>
                   </a:txBody>

</xml_diff>